<commit_message>
feat: mettre à jour la présentation HESTIM-Planner-pitch.pptx
</commit_message>
<xml_diff>
--- a/docs/presentation/HESTIM-Planner-pitch.pptx
+++ b/docs/presentation/HESTIM-Planner-pitch.pptx
@@ -150,7 +150,7 @@
     </p:spTree>
     <p:extLst>
       <p:ext uri="{BB962C8B-B14F-4D97-AF65-F5344CB8AC3E}">
-        <p14:creationId xmlns:p14="http://schemas.microsoft.com/office/powerpoint/2010/main" val="3229846798"/>
+        <p14:creationId xmlns:p14="http://schemas.microsoft.com/office/powerpoint/2010/main" val="3999976263"/>
       </p:ext>
     </p:extLst>
   </p:cSld>
@@ -601,7 +601,7 @@
         <p:txBody>
           <a:bodyPr wrap="square" rtlCol="0"/>
           <a:lstStyle>
-            <a:lvl1pPr marL="0" indent="0">
+            <a:lvl1pPr marL="0" indent="0" algn="l">
               <a:buNone/>
               <a:defRPr lang="en-US" sz="4000" b="1" dirty="0">
                 <a:solidFill>
@@ -614,7 +614,7 @@
             </a:lvl1pPr>
           </a:lstStyle>
           <a:p>
-            <a:pPr marL="0" indent="0">
+            <a:pPr marL="0" indent="0" algn="l">
               <a:buNone/>
             </a:pPr>
             <a:endParaRPr lang="en-US" sz="4000" dirty="0"/>
@@ -1267,7 +1267,7 @@
           <a:bodyPr wrap="square" lIns="0" tIns="0" rIns="0" bIns="0" rtlCol="0" anchor="ctr"/>
           <a:lstStyle/>
           <a:p>
-            <a:pPr marL="0" indent="0">
+            <a:pPr marL="0" indent="0" algn="l">
               <a:buNone/>
             </a:pPr>
             <a:r>
@@ -2455,7 +2455,7 @@
           <a:bodyPr wrap="square" lIns="0" tIns="0" rIns="0" bIns="0" rtlCol="0" anchor="ctr"/>
           <a:lstStyle/>
           <a:p>
-            <a:pPr marL="0" indent="0">
+            <a:pPr marL="0" indent="0" algn="l">
               <a:buNone/>
             </a:pPr>
             <a:r>
@@ -2595,7 +2595,7 @@
                 <a:ea typeface="Barlow Condensed" pitchFamily="34" charset="-122"/>
                 <a:cs typeface="Barlow Condensed" pitchFamily="34" charset="-120"/>
               </a:rPr>
-              <a:t>LE SEMESTRE SE CONSTRUIT SEUL</a:t>
+              <a:t>L'EDT SE CONSTRUIT SEUL</a:t>
             </a:r>
             <a:endParaRPr lang="en-US" sz="1900" dirty="0"/>
           </a:p>
@@ -3405,7 +3405,7 @@
           <a:bodyPr wrap="square" lIns="0" tIns="0" rIns="0" bIns="0" rtlCol="0" anchor="ctr"/>
           <a:lstStyle/>
           <a:p>
-            <a:pPr marL="0" indent="0">
+            <a:pPr marL="0" indent="0" algn="l">
               <a:buNone/>
             </a:pPr>
             <a:r>

</xml_diff>

<commit_message>
feat: Ajouter la présentation HESTIM Planner pour les investisseurs
</commit_message>
<xml_diff>
--- a/docs/presentation/HESTIM-Planner-pitch.pptx
+++ b/docs/presentation/HESTIM-Planner-pitch.pptx
@@ -680,7 +680,7 @@
           </a:prstGeom>
           <a:extLst>
             <a:ext uri="{C572A759-6A51-4108-AA02-DFA0A04FC94B}">
-              <ma14:wrappingTextBoxFlag xmlns:ma14="http://schemas.microsoft.com/office/mac/drawingml/2011/main" xmlns="" val="0"/>
+              <ma14:wrappingTextBoxFlag xmlns="" xmlns:ma14="http://schemas.microsoft.com/office/mac/drawingml/2011/main" val="0"/>
             </a:ext>
           </a:extLst>
         </p:spPr>
@@ -758,7 +758,7 @@
           </a:prstGeom>
           <a:extLst>
             <a:ext uri="{C572A759-6A51-4108-AA02-DFA0A04FC94B}">
-              <ma14:wrappingTextBoxFlag xmlns:ma14="http://schemas.microsoft.com/office/mac/drawingml/2011/main" xmlns="" val="0"/>
+              <ma14:wrappingTextBoxFlag xmlns="" xmlns:ma14="http://schemas.microsoft.com/office/mac/drawingml/2011/main" val="0"/>
             </a:ext>
           </a:extLst>
         </p:spPr>
@@ -1090,6 +1090,13 @@
             <a:prstDash val="solid"/>
           </a:ln>
         </p:spPr>
+        <p:txBody>
+          <a:bodyPr/>
+          <a:lstStyle/>
+          <a:p>
+            <a:endParaRPr lang="fr-FR"/>
+          </a:p>
+        </p:txBody>
       </p:sp>
       <p:sp>
         <p:nvSpPr>
@@ -1152,6 +1159,13 @@
             <a:prstDash val="solid"/>
           </a:ln>
         </p:spPr>
+        <p:txBody>
+          <a:bodyPr/>
+          <a:lstStyle/>
+          <a:p>
+            <a:endParaRPr lang="fr-FR"/>
+          </a:p>
+        </p:txBody>
       </p:sp>
       <p:sp>
         <p:nvSpPr>
@@ -1179,6 +1193,13 @@
             <a:prstDash val="solid"/>
           </a:ln>
         </p:spPr>
+        <p:txBody>
+          <a:bodyPr/>
+          <a:lstStyle/>
+          <a:p>
+            <a:endParaRPr lang="fr-FR"/>
+          </a:p>
+        </p:txBody>
       </p:sp>
       <p:sp>
         <p:nvSpPr>
@@ -1241,6 +1262,13 @@
             <a:prstDash val="solid"/>
           </a:ln>
         </p:spPr>
+        <p:txBody>
+          <a:bodyPr/>
+          <a:lstStyle/>
+          <a:p>
+            <a:endParaRPr lang="fr-FR"/>
+          </a:p>
+        </p:txBody>
       </p:sp>
       <p:sp>
         <p:nvSpPr>
@@ -1311,6 +1339,13 @@
             <a:prstDash val="solid"/>
           </a:ln>
         </p:spPr>
+        <p:txBody>
+          <a:bodyPr/>
+          <a:lstStyle/>
+          <a:p>
+            <a:endParaRPr lang="fr-FR"/>
+          </a:p>
+        </p:txBody>
       </p:sp>
       <p:sp>
         <p:nvSpPr>
@@ -1451,6 +1486,13 @@
             <a:prstDash val="solid"/>
           </a:ln>
         </p:spPr>
+        <p:txBody>
+          <a:bodyPr/>
+          <a:lstStyle/>
+          <a:p>
+            <a:endParaRPr lang="fr-FR"/>
+          </a:p>
+        </p:txBody>
       </p:sp>
       <p:sp>
         <p:nvSpPr>
@@ -1591,6 +1633,13 @@
             <a:prstDash val="solid"/>
           </a:ln>
         </p:spPr>
+        <p:txBody>
+          <a:bodyPr/>
+          <a:lstStyle/>
+          <a:p>
+            <a:endParaRPr lang="fr-FR"/>
+          </a:p>
+        </p:txBody>
       </p:sp>
       <p:sp>
         <p:nvSpPr>
@@ -1731,6 +1780,13 @@
             <a:prstDash val="solid"/>
           </a:ln>
         </p:spPr>
+        <p:txBody>
+          <a:bodyPr/>
+          <a:lstStyle/>
+          <a:p>
+            <a:endParaRPr lang="fr-FR"/>
+          </a:p>
+        </p:txBody>
       </p:sp>
       <p:sp>
         <p:nvSpPr>
@@ -1871,6 +1927,13 @@
             <a:prstDash val="solid"/>
           </a:ln>
         </p:spPr>
+        <p:txBody>
+          <a:bodyPr/>
+          <a:lstStyle/>
+          <a:p>
+            <a:endParaRPr lang="fr-FR"/>
+          </a:p>
+        </p:txBody>
       </p:sp>
       <p:sp>
         <p:nvSpPr>
@@ -2015,6 +2078,13 @@
             <a:prstDash val="solid"/>
           </a:ln>
         </p:spPr>
+        <p:txBody>
+          <a:bodyPr/>
+          <a:lstStyle/>
+          <a:p>
+            <a:endParaRPr lang="fr-FR"/>
+          </a:p>
+        </p:txBody>
       </p:sp>
       <p:sp>
         <p:nvSpPr>
@@ -2077,6 +2147,13 @@
             <a:prstDash val="solid"/>
           </a:ln>
         </p:spPr>
+        <p:txBody>
+          <a:bodyPr/>
+          <a:lstStyle/>
+          <a:p>
+            <a:endParaRPr lang="fr-FR"/>
+          </a:p>
+        </p:txBody>
       </p:sp>
       <p:sp>
         <p:nvSpPr>
@@ -2199,7 +2276,7 @@
           </a:prstGeom>
           <a:extLst>
             <a:ext uri="{C572A759-6A51-4108-AA02-DFA0A04FC94B}">
-              <ma14:wrappingTextBoxFlag xmlns:ma14="http://schemas.microsoft.com/office/mac/drawingml/2011/main" xmlns="" val="0"/>
+              <ma14:wrappingTextBoxFlag xmlns="" xmlns:ma14="http://schemas.microsoft.com/office/mac/drawingml/2011/main" val="0"/>
             </a:ext>
           </a:extLst>
         </p:spPr>
@@ -2278,6 +2355,13 @@
             <a:prstDash val="solid"/>
           </a:ln>
         </p:spPr>
+        <p:txBody>
+          <a:bodyPr/>
+          <a:lstStyle/>
+          <a:p>
+            <a:endParaRPr lang="fr-FR"/>
+          </a:p>
+        </p:txBody>
       </p:sp>
       <p:sp>
         <p:nvSpPr>
@@ -2340,6 +2424,13 @@
             <a:prstDash val="solid"/>
           </a:ln>
         </p:spPr>
+        <p:txBody>
+          <a:bodyPr/>
+          <a:lstStyle/>
+          <a:p>
+            <a:endParaRPr lang="fr-FR"/>
+          </a:p>
+        </p:txBody>
       </p:sp>
       <p:sp>
         <p:nvSpPr>
@@ -2367,6 +2458,13 @@
             <a:prstDash val="solid"/>
           </a:ln>
         </p:spPr>
+        <p:txBody>
+          <a:bodyPr/>
+          <a:lstStyle/>
+          <a:p>
+            <a:endParaRPr lang="fr-FR"/>
+          </a:p>
+        </p:txBody>
       </p:sp>
       <p:sp>
         <p:nvSpPr>
@@ -2429,6 +2527,13 @@
             <a:prstDash val="solid"/>
           </a:ln>
         </p:spPr>
+        <p:txBody>
+          <a:bodyPr/>
+          <a:lstStyle/>
+          <a:p>
+            <a:endParaRPr lang="fr-FR"/>
+          </a:p>
+        </p:txBody>
       </p:sp>
       <p:sp>
         <p:nvSpPr>
@@ -2499,6 +2604,13 @@
             <a:prstDash val="solid"/>
           </a:ln>
         </p:spPr>
+        <p:txBody>
+          <a:bodyPr/>
+          <a:lstStyle/>
+          <a:p>
+            <a:endParaRPr lang="fr-FR"/>
+          </a:p>
+        </p:txBody>
       </p:sp>
       <p:sp>
         <p:nvSpPr>
@@ -2561,6 +2673,13 @@
             <a:prstDash val="solid"/>
           </a:ln>
         </p:spPr>
+        <p:txBody>
+          <a:bodyPr/>
+          <a:lstStyle/>
+          <a:p>
+            <a:endParaRPr lang="fr-FR"/>
+          </a:p>
+        </p:txBody>
       </p:sp>
       <p:sp>
         <p:nvSpPr>
@@ -2666,6 +2785,13 @@
             <a:prstDash val="solid"/>
           </a:ln>
         </p:spPr>
+        <p:txBody>
+          <a:bodyPr/>
+          <a:lstStyle/>
+          <a:p>
+            <a:endParaRPr lang="fr-FR"/>
+          </a:p>
+        </p:txBody>
       </p:sp>
       <p:sp>
         <p:nvSpPr>
@@ -2728,6 +2854,13 @@
             <a:prstDash val="solid"/>
           </a:ln>
         </p:spPr>
+        <p:txBody>
+          <a:bodyPr/>
+          <a:lstStyle/>
+          <a:p>
+            <a:endParaRPr lang="fr-FR"/>
+          </a:p>
+        </p:txBody>
       </p:sp>
       <p:sp>
         <p:nvSpPr>
@@ -2833,6 +2966,13 @@
             <a:prstDash val="solid"/>
           </a:ln>
         </p:spPr>
+        <p:txBody>
+          <a:bodyPr/>
+          <a:lstStyle/>
+          <a:p>
+            <a:endParaRPr lang="fr-FR"/>
+          </a:p>
+        </p:txBody>
       </p:sp>
       <p:sp>
         <p:nvSpPr>
@@ -2895,6 +3035,13 @@
             <a:prstDash val="solid"/>
           </a:ln>
         </p:spPr>
+        <p:txBody>
+          <a:bodyPr/>
+          <a:lstStyle/>
+          <a:p>
+            <a:endParaRPr lang="fr-FR"/>
+          </a:p>
+        </p:txBody>
       </p:sp>
       <p:sp>
         <p:nvSpPr>
@@ -3007,6 +3154,13 @@
             </a:outerShdw>
           </a:effectLst>
         </p:spPr>
+        <p:txBody>
+          <a:bodyPr/>
+          <a:lstStyle/>
+          <a:p>
+            <a:endParaRPr lang="fr-FR"/>
+          </a:p>
+        </p:txBody>
       </p:sp>
       <p:pic>
         <p:nvPicPr>
@@ -3065,6 +3219,13 @@
             </a:outerShdw>
           </a:effectLst>
         </p:spPr>
+        <p:txBody>
+          <a:bodyPr/>
+          <a:lstStyle/>
+          <a:p>
+            <a:endParaRPr lang="fr-FR"/>
+          </a:p>
+        </p:txBody>
       </p:sp>
       <p:pic>
         <p:nvPicPr>
@@ -3149,7 +3310,7 @@
           </a:prstGeom>
           <a:extLst>
             <a:ext uri="{C572A759-6A51-4108-AA02-DFA0A04FC94B}">
-              <ma14:wrappingTextBoxFlag xmlns:ma14="http://schemas.microsoft.com/office/mac/drawingml/2011/main" xmlns="" val="0"/>
+              <ma14:wrappingTextBoxFlag xmlns="" xmlns:ma14="http://schemas.microsoft.com/office/mac/drawingml/2011/main" val="0"/>
             </a:ext>
           </a:extLst>
         </p:spPr>
@@ -3228,6 +3389,13 @@
             <a:prstDash val="solid"/>
           </a:ln>
         </p:spPr>
+        <p:txBody>
+          <a:bodyPr/>
+          <a:lstStyle/>
+          <a:p>
+            <a:endParaRPr lang="fr-FR"/>
+          </a:p>
+        </p:txBody>
       </p:sp>
       <p:sp>
         <p:nvSpPr>
@@ -3290,6 +3458,13 @@
             <a:prstDash val="solid"/>
           </a:ln>
         </p:spPr>
+        <p:txBody>
+          <a:bodyPr/>
+          <a:lstStyle/>
+          <a:p>
+            <a:endParaRPr lang="fr-FR"/>
+          </a:p>
+        </p:txBody>
       </p:sp>
       <p:sp>
         <p:nvSpPr>
@@ -3317,6 +3492,13 @@
             <a:prstDash val="solid"/>
           </a:ln>
         </p:spPr>
+        <p:txBody>
+          <a:bodyPr/>
+          <a:lstStyle/>
+          <a:p>
+            <a:endParaRPr lang="fr-FR"/>
+          </a:p>
+        </p:txBody>
       </p:sp>
       <p:sp>
         <p:nvSpPr>
@@ -3379,6 +3561,13 @@
             <a:prstDash val="solid"/>
           </a:ln>
         </p:spPr>
+        <p:txBody>
+          <a:bodyPr/>
+          <a:lstStyle/>
+          <a:p>
+            <a:endParaRPr lang="fr-FR"/>
+          </a:p>
+        </p:txBody>
       </p:sp>
       <p:sp>
         <p:nvSpPr>
@@ -3449,6 +3638,13 @@
             <a:prstDash val="solid"/>
           </a:ln>
         </p:spPr>
+        <p:txBody>
+          <a:bodyPr/>
+          <a:lstStyle/>
+          <a:p>
+            <a:endParaRPr lang="fr-FR"/>
+          </a:p>
+        </p:txBody>
       </p:sp>
       <p:sp>
         <p:nvSpPr>
@@ -3511,6 +3707,13 @@
             <a:prstDash val="solid"/>
           </a:ln>
         </p:spPr>
+        <p:txBody>
+          <a:bodyPr/>
+          <a:lstStyle/>
+          <a:p>
+            <a:endParaRPr lang="fr-FR"/>
+          </a:p>
+        </p:txBody>
       </p:sp>
       <p:sp>
         <p:nvSpPr>
@@ -3538,6 +3741,13 @@
             <a:prstDash val="solid"/>
           </a:ln>
         </p:spPr>
+        <p:txBody>
+          <a:bodyPr/>
+          <a:lstStyle/>
+          <a:p>
+            <a:endParaRPr lang="fr-FR"/>
+          </a:p>
+        </p:txBody>
       </p:sp>
       <p:sp>
         <p:nvSpPr>
@@ -3600,6 +3810,13 @@
             <a:prstDash val="solid"/>
           </a:ln>
         </p:spPr>
+        <p:txBody>
+          <a:bodyPr/>
+          <a:lstStyle/>
+          <a:p>
+            <a:endParaRPr lang="fr-FR"/>
+          </a:p>
+        </p:txBody>
       </p:sp>
       <p:sp>
         <p:nvSpPr>
@@ -3627,6 +3844,13 @@
             <a:prstDash val="solid"/>
           </a:ln>
         </p:spPr>
+        <p:txBody>
+          <a:bodyPr/>
+          <a:lstStyle/>
+          <a:p>
+            <a:endParaRPr lang="fr-FR"/>
+          </a:p>
+        </p:txBody>
       </p:sp>
       <p:sp>
         <p:nvSpPr>
@@ -3689,6 +3913,13 @@
             <a:prstDash val="solid"/>
           </a:ln>
         </p:spPr>
+        <p:txBody>
+          <a:bodyPr/>
+          <a:lstStyle/>
+          <a:p>
+            <a:endParaRPr lang="fr-FR"/>
+          </a:p>
+        </p:txBody>
       </p:sp>
       <p:sp>
         <p:nvSpPr>
@@ -3716,6 +3947,13 @@
             <a:prstDash val="solid"/>
           </a:ln>
         </p:spPr>
+        <p:txBody>
+          <a:bodyPr/>
+          <a:lstStyle/>
+          <a:p>
+            <a:endParaRPr lang="fr-FR"/>
+          </a:p>
+        </p:txBody>
       </p:sp>
       <p:sp>
         <p:nvSpPr>
@@ -3778,6 +4016,13 @@
             <a:prstDash val="solid"/>
           </a:ln>
         </p:spPr>
+        <p:txBody>
+          <a:bodyPr/>
+          <a:lstStyle/>
+          <a:p>
+            <a:endParaRPr lang="fr-FR"/>
+          </a:p>
+        </p:txBody>
       </p:sp>
       <p:sp>
         <p:nvSpPr>
@@ -3844,6 +4089,13 @@
             <a:prstDash val="solid"/>
           </a:ln>
         </p:spPr>
+        <p:txBody>
+          <a:bodyPr/>
+          <a:lstStyle/>
+          <a:p>
+            <a:endParaRPr lang="fr-FR"/>
+          </a:p>
+        </p:txBody>
       </p:sp>
       <p:sp>
         <p:nvSpPr>
@@ -3906,6 +4158,13 @@
             <a:prstDash val="solid"/>
           </a:ln>
         </p:spPr>
+        <p:txBody>
+          <a:bodyPr/>
+          <a:lstStyle/>
+          <a:p>
+            <a:endParaRPr lang="fr-FR"/>
+          </a:p>
+        </p:txBody>
       </p:sp>
       <p:sp>
         <p:nvSpPr>
@@ -3933,6 +4192,13 @@
             <a:prstDash val="solid"/>
           </a:ln>
         </p:spPr>
+        <p:txBody>
+          <a:bodyPr/>
+          <a:lstStyle/>
+          <a:p>
+            <a:endParaRPr lang="fr-FR"/>
+          </a:p>
+        </p:txBody>
       </p:sp>
       <p:sp>
         <p:nvSpPr>
@@ -3995,6 +4261,13 @@
             <a:prstDash val="solid"/>
           </a:ln>
         </p:spPr>
+        <p:txBody>
+          <a:bodyPr/>
+          <a:lstStyle/>
+          <a:p>
+            <a:endParaRPr lang="fr-FR"/>
+          </a:p>
+        </p:txBody>
       </p:sp>
       <p:sp>
         <p:nvSpPr>
@@ -4061,6 +4334,13 @@
             <a:prstDash val="solid"/>
           </a:ln>
         </p:spPr>
+        <p:txBody>
+          <a:bodyPr/>
+          <a:lstStyle/>
+          <a:p>
+            <a:endParaRPr lang="fr-FR"/>
+          </a:p>
+        </p:txBody>
       </p:sp>
       <p:sp>
         <p:nvSpPr>
@@ -4123,6 +4403,13 @@
             <a:prstDash val="solid"/>
           </a:ln>
         </p:spPr>
+        <p:txBody>
+          <a:bodyPr/>
+          <a:lstStyle/>
+          <a:p>
+            <a:endParaRPr lang="fr-FR"/>
+          </a:p>
+        </p:txBody>
       </p:sp>
       <p:sp>
         <p:nvSpPr>
@@ -4150,6 +4437,13 @@
             <a:prstDash val="solid"/>
           </a:ln>
         </p:spPr>
+        <p:txBody>
+          <a:bodyPr/>
+          <a:lstStyle/>
+          <a:p>
+            <a:endParaRPr lang="fr-FR"/>
+          </a:p>
+        </p:txBody>
       </p:sp>
       <p:sp>
         <p:nvSpPr>
@@ -4212,6 +4506,13 @@
             <a:prstDash val="solid"/>
           </a:ln>
         </p:spPr>
+        <p:txBody>
+          <a:bodyPr/>
+          <a:lstStyle/>
+          <a:p>
+            <a:endParaRPr lang="fr-FR"/>
+          </a:p>
+        </p:txBody>
       </p:sp>
       <p:sp>
         <p:nvSpPr>
@@ -4239,6 +4540,13 @@
             <a:prstDash val="solid"/>
           </a:ln>
         </p:spPr>
+        <p:txBody>
+          <a:bodyPr/>
+          <a:lstStyle/>
+          <a:p>
+            <a:endParaRPr lang="fr-FR"/>
+          </a:p>
+        </p:txBody>
       </p:sp>
       <p:sp>
         <p:nvSpPr>
@@ -4301,6 +4609,13 @@
             <a:prstDash val="solid"/>
           </a:ln>
         </p:spPr>
+        <p:txBody>
+          <a:bodyPr/>
+          <a:lstStyle/>
+          <a:p>
+            <a:endParaRPr lang="fr-FR"/>
+          </a:p>
+        </p:txBody>
       </p:sp>
       <p:sp>
         <p:nvSpPr>
@@ -4402,6 +4717,13 @@
             <a:prstDash val="solid"/>
           </a:ln>
         </p:spPr>
+        <p:txBody>
+          <a:bodyPr/>
+          <a:lstStyle/>
+          <a:p>
+            <a:endParaRPr lang="fr-FR"/>
+          </a:p>
+        </p:txBody>
       </p:sp>
       <p:sp>
         <p:nvSpPr>
@@ -4542,6 +4864,13 @@
             <a:prstDash val="solid"/>
           </a:ln>
         </p:spPr>
+        <p:txBody>
+          <a:bodyPr/>
+          <a:lstStyle/>
+          <a:p>
+            <a:endParaRPr lang="fr-FR"/>
+          </a:p>
+        </p:txBody>
       </p:sp>
       <p:sp>
         <p:nvSpPr>
@@ -4682,6 +5011,13 @@
             <a:prstDash val="solid"/>
           </a:ln>
         </p:spPr>
+        <p:txBody>
+          <a:bodyPr/>
+          <a:lstStyle/>
+          <a:p>
+            <a:endParaRPr lang="fr-FR"/>
+          </a:p>
+        </p:txBody>
       </p:sp>
       <p:sp>
         <p:nvSpPr>
@@ -4822,6 +5158,13 @@
             <a:prstDash val="solid"/>
           </a:ln>
         </p:spPr>
+        <p:txBody>
+          <a:bodyPr/>
+          <a:lstStyle/>
+          <a:p>
+            <a:endParaRPr lang="fr-FR"/>
+          </a:p>
+        </p:txBody>
       </p:sp>
       <p:sp>
         <p:nvSpPr>
@@ -4962,6 +5305,13 @@
             <a:prstDash val="solid"/>
           </a:ln>
         </p:spPr>
+        <p:txBody>
+          <a:bodyPr/>
+          <a:lstStyle/>
+          <a:p>
+            <a:endParaRPr lang="fr-FR"/>
+          </a:p>
+        </p:txBody>
       </p:sp>
       <p:sp>
         <p:nvSpPr>
@@ -5102,6 +5452,13 @@
             <a:prstDash val="solid"/>
           </a:ln>
         </p:spPr>
+        <p:txBody>
+          <a:bodyPr/>
+          <a:lstStyle/>
+          <a:p>
+            <a:endParaRPr lang="fr-FR"/>
+          </a:p>
+        </p:txBody>
       </p:sp>
       <p:sp>
         <p:nvSpPr>
@@ -5246,6 +5603,13 @@
             <a:prstDash val="solid"/>
           </a:ln>
         </p:spPr>
+        <p:txBody>
+          <a:bodyPr/>
+          <a:lstStyle/>
+          <a:p>
+            <a:endParaRPr lang="fr-FR"/>
+          </a:p>
+        </p:txBody>
       </p:sp>
       <p:sp>
         <p:nvSpPr>
@@ -5308,6 +5672,13 @@
             <a:prstDash val="solid"/>
           </a:ln>
         </p:spPr>
+        <p:txBody>
+          <a:bodyPr/>
+          <a:lstStyle/>
+          <a:p>
+            <a:endParaRPr lang="fr-FR"/>
+          </a:p>
+        </p:txBody>
       </p:sp>
       <p:sp>
         <p:nvSpPr>
@@ -5335,6 +5706,13 @@
             <a:prstDash val="solid"/>
           </a:ln>
         </p:spPr>
+        <p:txBody>
+          <a:bodyPr/>
+          <a:lstStyle/>
+          <a:p>
+            <a:endParaRPr lang="fr-FR"/>
+          </a:p>
+        </p:txBody>
       </p:sp>
       <p:sp>
         <p:nvSpPr>
@@ -5397,6 +5775,13 @@
             <a:prstDash val="solid"/>
           </a:ln>
         </p:spPr>
+        <p:txBody>
+          <a:bodyPr/>
+          <a:lstStyle/>
+          <a:p>
+            <a:endParaRPr lang="fr-FR"/>
+          </a:p>
+        </p:txBody>
       </p:sp>
       <p:sp>
         <p:nvSpPr>
@@ -5424,6 +5809,13 @@
             <a:prstDash val="solid"/>
           </a:ln>
         </p:spPr>
+        <p:txBody>
+          <a:bodyPr/>
+          <a:lstStyle/>
+          <a:p>
+            <a:endParaRPr lang="fr-FR"/>
+          </a:p>
+        </p:txBody>
       </p:sp>
       <p:sp>
         <p:nvSpPr>
@@ -5486,6 +5878,13 @@
             <a:prstDash val="solid"/>
           </a:ln>
         </p:spPr>
+        <p:txBody>
+          <a:bodyPr/>
+          <a:lstStyle/>
+          <a:p>
+            <a:endParaRPr lang="fr-FR"/>
+          </a:p>
+        </p:txBody>
       </p:sp>
       <p:sp>
         <p:nvSpPr>
@@ -5513,6 +5912,13 @@
             <a:prstDash val="solid"/>
           </a:ln>
         </p:spPr>
+        <p:txBody>
+          <a:bodyPr/>
+          <a:lstStyle/>
+          <a:p>
+            <a:endParaRPr lang="fr-FR"/>
+          </a:p>
+        </p:txBody>
       </p:sp>
       <p:sp>
         <p:nvSpPr>
@@ -5575,6 +5981,13 @@
             <a:prstDash val="solid"/>
           </a:ln>
         </p:spPr>
+        <p:txBody>
+          <a:bodyPr/>
+          <a:lstStyle/>
+          <a:p>
+            <a:endParaRPr lang="fr-FR"/>
+          </a:p>
+        </p:txBody>
       </p:sp>
       <p:sp>
         <p:nvSpPr>
@@ -5602,6 +6015,13 @@
             <a:prstDash val="solid"/>
           </a:ln>
         </p:spPr>
+        <p:txBody>
+          <a:bodyPr/>
+          <a:lstStyle/>
+          <a:p>
+            <a:endParaRPr lang="fr-FR"/>
+          </a:p>
+        </p:txBody>
       </p:sp>
       <p:sp>
         <p:nvSpPr>
@@ -5664,6 +6084,13 @@
             <a:prstDash val="solid"/>
           </a:ln>
         </p:spPr>
+        <p:txBody>
+          <a:bodyPr/>
+          <a:lstStyle/>
+          <a:p>
+            <a:endParaRPr lang="fr-FR"/>
+          </a:p>
+        </p:txBody>
       </p:sp>
       <p:sp>
         <p:nvSpPr>
@@ -5691,6 +6118,13 @@
             <a:prstDash val="solid"/>
           </a:ln>
         </p:spPr>
+        <p:txBody>
+          <a:bodyPr/>
+          <a:lstStyle/>
+          <a:p>
+            <a:endParaRPr lang="fr-FR"/>
+          </a:p>
+        </p:txBody>
       </p:sp>
       <p:sp>
         <p:nvSpPr>
@@ -5753,6 +6187,13 @@
             <a:prstDash val="solid"/>
           </a:ln>
         </p:spPr>
+        <p:txBody>
+          <a:bodyPr/>
+          <a:lstStyle/>
+          <a:p>
+            <a:endParaRPr lang="fr-FR"/>
+          </a:p>
+        </p:txBody>
       </p:sp>
       <p:sp>
         <p:nvSpPr>
@@ -5780,6 +6221,13 @@
             <a:prstDash val="solid"/>
           </a:ln>
         </p:spPr>
+        <p:txBody>
+          <a:bodyPr/>
+          <a:lstStyle/>
+          <a:p>
+            <a:endParaRPr lang="fr-FR"/>
+          </a:p>
+        </p:txBody>
       </p:sp>
       <p:sp>
         <p:nvSpPr>
@@ -5842,6 +6290,13 @@
             <a:prstDash val="solid"/>
           </a:ln>
         </p:spPr>
+        <p:txBody>
+          <a:bodyPr/>
+          <a:lstStyle/>
+          <a:p>
+            <a:endParaRPr lang="fr-FR"/>
+          </a:p>
+        </p:txBody>
       </p:sp>
       <p:sp>
         <p:nvSpPr>
@@ -5869,6 +6324,13 @@
             <a:prstDash val="solid"/>
           </a:ln>
         </p:spPr>
+        <p:txBody>
+          <a:bodyPr/>
+          <a:lstStyle/>
+          <a:p>
+            <a:endParaRPr lang="fr-FR"/>
+          </a:p>
+        </p:txBody>
       </p:sp>
       <p:sp>
         <p:nvSpPr>
@@ -5931,6 +6393,13 @@
             <a:prstDash val="solid"/>
           </a:ln>
         </p:spPr>
+        <p:txBody>
+          <a:bodyPr/>
+          <a:lstStyle/>
+          <a:p>
+            <a:endParaRPr lang="fr-FR"/>
+          </a:p>
+        </p:txBody>
       </p:sp>
       <p:sp>
         <p:nvSpPr>
@@ -5958,6 +6427,13 @@
             <a:prstDash val="solid"/>
           </a:ln>
         </p:spPr>
+        <p:txBody>
+          <a:bodyPr/>
+          <a:lstStyle/>
+          <a:p>
+            <a:endParaRPr lang="fr-FR"/>
+          </a:p>
+        </p:txBody>
       </p:sp>
       <p:sp>
         <p:nvSpPr>
@@ -6020,6 +6496,13 @@
             <a:prstDash val="solid"/>
           </a:ln>
         </p:spPr>
+        <p:txBody>
+          <a:bodyPr/>
+          <a:lstStyle/>
+          <a:p>
+            <a:endParaRPr lang="fr-FR"/>
+          </a:p>
+        </p:txBody>
       </p:sp>
       <p:sp>
         <p:nvSpPr>
@@ -6047,6 +6530,13 @@
             <a:prstDash val="solid"/>
           </a:ln>
         </p:spPr>
+        <p:txBody>
+          <a:bodyPr/>
+          <a:lstStyle/>
+          <a:p>
+            <a:endParaRPr lang="fr-FR"/>
+          </a:p>
+        </p:txBody>
       </p:sp>
       <p:sp>
         <p:nvSpPr>
@@ -6109,6 +6599,13 @@
             <a:prstDash val="solid"/>
           </a:ln>
         </p:spPr>
+        <p:txBody>
+          <a:bodyPr/>
+          <a:lstStyle/>
+          <a:p>
+            <a:endParaRPr lang="fr-FR"/>
+          </a:p>
+        </p:txBody>
       </p:sp>
       <p:sp>
         <p:nvSpPr>
@@ -6136,6 +6633,13 @@
             <a:prstDash val="solid"/>
           </a:ln>
         </p:spPr>
+        <p:txBody>
+          <a:bodyPr/>
+          <a:lstStyle/>
+          <a:p>
+            <a:endParaRPr lang="fr-FR"/>
+          </a:p>
+        </p:txBody>
       </p:sp>
       <p:sp>
         <p:nvSpPr>
@@ -6198,6 +6702,13 @@
             <a:prstDash val="solid"/>
           </a:ln>
         </p:spPr>
+        <p:txBody>
+          <a:bodyPr/>
+          <a:lstStyle/>
+          <a:p>
+            <a:endParaRPr lang="fr-FR"/>
+          </a:p>
+        </p:txBody>
       </p:sp>
       <p:sp>
         <p:nvSpPr>
@@ -6225,6 +6736,13 @@
             <a:prstDash val="solid"/>
           </a:ln>
         </p:spPr>
+        <p:txBody>
+          <a:bodyPr/>
+          <a:lstStyle/>
+          <a:p>
+            <a:endParaRPr lang="fr-FR"/>
+          </a:p>
+        </p:txBody>
       </p:sp>
       <p:sp>
         <p:nvSpPr>
@@ -6287,6 +6805,13 @@
             <a:prstDash val="solid"/>
           </a:ln>
         </p:spPr>
+        <p:txBody>
+          <a:bodyPr/>
+          <a:lstStyle/>
+          <a:p>
+            <a:endParaRPr lang="fr-FR"/>
+          </a:p>
+        </p:txBody>
       </p:sp>
       <p:sp>
         <p:nvSpPr>
@@ -6314,6 +6839,13 @@
             <a:prstDash val="solid"/>
           </a:ln>
         </p:spPr>
+        <p:txBody>
+          <a:bodyPr/>
+          <a:lstStyle/>
+          <a:p>
+            <a:endParaRPr lang="fr-FR"/>
+          </a:p>
+        </p:txBody>
       </p:sp>
       <p:sp>
         <p:nvSpPr>
@@ -6376,6 +6908,13 @@
             <a:prstDash val="solid"/>
           </a:ln>
         </p:spPr>
+        <p:txBody>
+          <a:bodyPr/>
+          <a:lstStyle/>
+          <a:p>
+            <a:endParaRPr lang="fr-FR"/>
+          </a:p>
+        </p:txBody>
       </p:sp>
       <p:sp>
         <p:nvSpPr>
@@ -6403,6 +6942,13 @@
             <a:prstDash val="solid"/>
           </a:ln>
         </p:spPr>
+        <p:txBody>
+          <a:bodyPr/>
+          <a:lstStyle/>
+          <a:p>
+            <a:endParaRPr lang="fr-FR"/>
+          </a:p>
+        </p:txBody>
       </p:sp>
       <p:sp>
         <p:nvSpPr>
@@ -6465,6 +7011,13 @@
             <a:prstDash val="solid"/>
           </a:ln>
         </p:spPr>
+        <p:txBody>
+          <a:bodyPr/>
+          <a:lstStyle/>
+          <a:p>
+            <a:endParaRPr lang="fr-FR"/>
+          </a:p>
+        </p:txBody>
       </p:sp>
       <p:sp>
         <p:nvSpPr>
@@ -6492,6 +7045,13 @@
             <a:prstDash val="solid"/>
           </a:ln>
         </p:spPr>
+        <p:txBody>
+          <a:bodyPr/>
+          <a:lstStyle/>
+          <a:p>
+            <a:endParaRPr lang="fr-FR"/>
+          </a:p>
+        </p:txBody>
       </p:sp>
       <p:sp>
         <p:nvSpPr>
@@ -6554,6 +7114,13 @@
             <a:prstDash val="solid"/>
           </a:ln>
         </p:spPr>
+        <p:txBody>
+          <a:bodyPr/>
+          <a:lstStyle/>
+          <a:p>
+            <a:endParaRPr lang="fr-FR"/>
+          </a:p>
+        </p:txBody>
       </p:sp>
       <p:sp>
         <p:nvSpPr>
@@ -6581,6 +7148,13 @@
             <a:prstDash val="solid"/>
           </a:ln>
         </p:spPr>
+        <p:txBody>
+          <a:bodyPr/>
+          <a:lstStyle/>
+          <a:p>
+            <a:endParaRPr lang="fr-FR"/>
+          </a:p>
+        </p:txBody>
       </p:sp>
       <p:sp>
         <p:nvSpPr>
@@ -6643,6 +7217,13 @@
             <a:prstDash val="solid"/>
           </a:ln>
         </p:spPr>
+        <p:txBody>
+          <a:bodyPr/>
+          <a:lstStyle/>
+          <a:p>
+            <a:endParaRPr lang="fr-FR"/>
+          </a:p>
+        </p:txBody>
       </p:sp>
       <p:sp>
         <p:nvSpPr>
@@ -6670,6 +7251,13 @@
             <a:prstDash val="solid"/>
           </a:ln>
         </p:spPr>
+        <p:txBody>
+          <a:bodyPr/>
+          <a:lstStyle/>
+          <a:p>
+            <a:endParaRPr lang="fr-FR"/>
+          </a:p>
+        </p:txBody>
       </p:sp>
       <p:sp>
         <p:nvSpPr>
@@ -6732,6 +7320,13 @@
             <a:prstDash val="solid"/>
           </a:ln>
         </p:spPr>
+        <p:txBody>
+          <a:bodyPr/>
+          <a:lstStyle/>
+          <a:p>
+            <a:endParaRPr lang="fr-FR"/>
+          </a:p>
+        </p:txBody>
       </p:sp>
       <p:sp>
         <p:nvSpPr>
@@ -6759,6 +7354,13 @@
             <a:prstDash val="solid"/>
           </a:ln>
         </p:spPr>
+        <p:txBody>
+          <a:bodyPr/>
+          <a:lstStyle/>
+          <a:p>
+            <a:endParaRPr lang="fr-FR"/>
+          </a:p>
+        </p:txBody>
       </p:sp>
       <p:sp>
         <p:nvSpPr>
@@ -6821,6 +7423,13 @@
             <a:prstDash val="solid"/>
           </a:ln>
         </p:spPr>
+        <p:txBody>
+          <a:bodyPr/>
+          <a:lstStyle/>
+          <a:p>
+            <a:endParaRPr lang="fr-FR"/>
+          </a:p>
+        </p:txBody>
       </p:sp>
       <p:sp>
         <p:nvSpPr>
@@ -6848,6 +7457,13 @@
             <a:prstDash val="solid"/>
           </a:ln>
         </p:spPr>
+        <p:txBody>
+          <a:bodyPr/>
+          <a:lstStyle/>
+          <a:p>
+            <a:endParaRPr lang="fr-FR"/>
+          </a:p>
+        </p:txBody>
       </p:sp>
       <p:sp>
         <p:nvSpPr>
@@ -6910,6 +7526,13 @@
             <a:prstDash val="solid"/>
           </a:ln>
         </p:spPr>
+        <p:txBody>
+          <a:bodyPr/>
+          <a:lstStyle/>
+          <a:p>
+            <a:endParaRPr lang="fr-FR"/>
+          </a:p>
+        </p:txBody>
       </p:sp>
       <p:sp>
         <p:nvSpPr>
@@ -6937,6 +7560,13 @@
             <a:prstDash val="solid"/>
           </a:ln>
         </p:spPr>
+        <p:txBody>
+          <a:bodyPr/>
+          <a:lstStyle/>
+          <a:p>
+            <a:endParaRPr lang="fr-FR"/>
+          </a:p>
+        </p:txBody>
       </p:sp>
       <p:sp>
         <p:nvSpPr>
@@ -6999,6 +7629,13 @@
             <a:prstDash val="solid"/>
           </a:ln>
         </p:spPr>
+        <p:txBody>
+          <a:bodyPr/>
+          <a:lstStyle/>
+          <a:p>
+            <a:endParaRPr lang="fr-FR"/>
+          </a:p>
+        </p:txBody>
       </p:sp>
       <p:sp>
         <p:nvSpPr>
@@ -7026,6 +7663,13 @@
             <a:prstDash val="solid"/>
           </a:ln>
         </p:spPr>
+        <p:txBody>
+          <a:bodyPr/>
+          <a:lstStyle/>
+          <a:p>
+            <a:endParaRPr lang="fr-FR"/>
+          </a:p>
+        </p:txBody>
       </p:sp>
       <p:sp>
         <p:nvSpPr>
@@ -7088,6 +7732,13 @@
             <a:prstDash val="solid"/>
           </a:ln>
         </p:spPr>
+        <p:txBody>
+          <a:bodyPr/>
+          <a:lstStyle/>
+          <a:p>
+            <a:endParaRPr lang="fr-FR"/>
+          </a:p>
+        </p:txBody>
       </p:sp>
       <p:sp>
         <p:nvSpPr>
@@ -7115,6 +7766,13 @@
             <a:prstDash val="solid"/>
           </a:ln>
         </p:spPr>
+        <p:txBody>
+          <a:bodyPr/>
+          <a:lstStyle/>
+          <a:p>
+            <a:endParaRPr lang="fr-FR"/>
+          </a:p>
+        </p:txBody>
       </p:sp>
       <p:sp>
         <p:nvSpPr>
@@ -7177,6 +7835,13 @@
             <a:prstDash val="solid"/>
           </a:ln>
         </p:spPr>
+        <p:txBody>
+          <a:bodyPr/>
+          <a:lstStyle/>
+          <a:p>
+            <a:endParaRPr lang="fr-FR"/>
+          </a:p>
+        </p:txBody>
       </p:sp>
       <p:sp>
         <p:nvSpPr>
@@ -7204,6 +7869,13 @@
             <a:prstDash val="solid"/>
           </a:ln>
         </p:spPr>
+        <p:txBody>
+          <a:bodyPr/>
+          <a:lstStyle/>
+          <a:p>
+            <a:endParaRPr lang="fr-FR"/>
+          </a:p>
+        </p:txBody>
       </p:sp>
       <p:sp>
         <p:nvSpPr>
@@ -7266,6 +7938,13 @@
             <a:prstDash val="solid"/>
           </a:ln>
         </p:spPr>
+        <p:txBody>
+          <a:bodyPr/>
+          <a:lstStyle/>
+          <a:p>
+            <a:endParaRPr lang="fr-FR"/>
+          </a:p>
+        </p:txBody>
       </p:sp>
       <p:sp>
         <p:nvSpPr>
@@ -7326,7 +8005,7 @@
           </a:prstGeom>
           <a:extLst>
             <a:ext uri="{C572A759-6A51-4108-AA02-DFA0A04FC94B}">
-              <ma14:wrappingTextBoxFlag xmlns:ma14="http://schemas.microsoft.com/office/mac/drawingml/2011/main" xmlns="" val="0"/>
+              <ma14:wrappingTextBoxFlag xmlns="" xmlns:ma14="http://schemas.microsoft.com/office/mac/drawingml/2011/main" val="0"/>
             </a:ext>
           </a:extLst>
         </p:spPr>
@@ -7970,4 +8649,39 @@
     </a:ext>
   </a:extLst>
 </a:theme>
+</file>
+
+<file path=ppt/webextensions/taskpanes.xml><?xml version="1.0" encoding="utf-8"?>
+<wetp:taskpanes xmlns:wetp="http://schemas.microsoft.com/office/webextensions/taskpanes/2010/11">
+  <wetp:taskpane dockstate="right" visibility="0" width="350" row="0">
+    <wetp:webextensionref xmlns:r="http://schemas.openxmlformats.org/officeDocument/2006/relationships" r:id="rId1"/>
+  </wetp:taskpane>
+  <wetp:taskpane dockstate="right" visibility="0" width="350" row="1">
+    <wetp:webextensionref xmlns:r="http://schemas.openxmlformats.org/officeDocument/2006/relationships" r:id="rId2"/>
+  </wetp:taskpane>
+</wetp:taskpanes>
+</file>
+
+<file path=ppt/webextensions/webextension1.xml><?xml version="1.0" encoding="utf-8"?>
+<we:webextension xmlns:we="http://schemas.microsoft.com/office/webextensions/webextension/2010/11" id="{D373EBE1-40E8-4183-8990-08CCB767FE7B}">
+  <we:reference id="wa200010001" version="1.0.0.1" store="fr-FR" storeType="OMEX"/>
+  <we:alternateReferences>
+    <we:reference id="wa200010001" version="1.0.0.1" store="wa200010001" storeType="OMEX"/>
+  </we:alternateReferences>
+  <we:properties/>
+  <we:bindings/>
+  <we:snapshot xmlns:r="http://schemas.openxmlformats.org/officeDocument/2006/relationships"/>
+</we:webextension>
+</file>
+
+<file path=ppt/webextensions/webextension2.xml><?xml version="1.0" encoding="utf-8"?>
+<we:webextension xmlns:we="http://schemas.microsoft.com/office/webextensions/webextension/2010/11" id="{373DB53F-97E7-4114-8CFB-6E8625A4D6C5}">
+  <we:reference id="wa200010215" version="2.0.0.0" store="fr-FR" storeType="OMEX"/>
+  <we:alternateReferences>
+    <we:reference id="wa200010215" version="2.0.0.0" store="wa200010215" storeType="OMEX"/>
+  </we:alternateReferences>
+  <we:properties/>
+  <we:bindings/>
+  <we:snapshot xmlns:r="http://schemas.openxmlformats.org/officeDocument/2006/relationships"/>
+</we:webextension>
 </file>
</xml_diff>